<commit_message>
Rewrite Lecture 9: pair the main/cross-axis diagram with real flex code
Almost every image slide in this deck already had a matching code slide
right before it -- the one gap was the main-axis/cross-axis diagram,
which had only descriptive text. Converted it to codeImage with the
display: flex rule that actually produced it.

Co-Authored-By: Claude Sonnet 5 <noreply@anthropic.com>
</commit_message>
<xml_diff>
--- a/slides/CSC336-Lecture-09-Flexbox-and-Grid-Layout.pptx
+++ b/slides/CSC336-Lecture-09-Flexbox-and-Grid-Layout.pptx
@@ -4188,11 +4188,11 @@
         <p:spPr>
           <a:xfrm>
             <a:off x="640080" y="1965960"/>
-            <a:ext cx="10911535" cy="1069848"/>
+            <a:ext cx="10911535" cy="815340"/>
           </a:xfrm>
           <a:prstGeom prst="roundRect">
             <a:avLst>
-              <a:gd name="adj" fmla="val 6838"/>
+              <a:gd name="adj" fmla="val 8972"/>
             </a:avLst>
           </a:prstGeom>
           <a:solidFill>
@@ -4210,7 +4210,7 @@
         <p:spPr>
           <a:xfrm>
             <a:off x="960120" y="2194560"/>
-            <a:ext cx="10271455" cy="612648"/>
+            <a:ext cx="10271455" cy="358140"/>
           </a:xfrm>
           <a:prstGeom prst="rect">
             <a:avLst/>
@@ -4686,11 +4686,11 @@
         <p:spPr>
           <a:xfrm>
             <a:off x="640080" y="1965960"/>
-            <a:ext cx="10911535" cy="2606040"/>
+            <a:ext cx="10911535" cy="1882140"/>
           </a:xfrm>
           <a:prstGeom prst="roundRect">
             <a:avLst>
-              <a:gd name="adj" fmla="val 2807"/>
+              <a:gd name="adj" fmla="val 3887"/>
             </a:avLst>
           </a:prstGeom>
           <a:solidFill>
@@ -4708,7 +4708,7 @@
         <p:spPr>
           <a:xfrm>
             <a:off x="960120" y="2194560"/>
-            <a:ext cx="10271455" cy="2148840"/>
+            <a:ext cx="10271455" cy="1424940"/>
           </a:xfrm>
           <a:prstGeom prst="rect">
             <a:avLst/>
@@ -4829,8 +4829,8 @@
         </p:nvSpPr>
         <p:spPr>
           <a:xfrm>
-            <a:off x="640080" y="4800600"/>
-            <a:ext cx="10911535" cy="1463040"/>
+            <a:off x="640080" y="4076700"/>
+            <a:ext cx="10911535" cy="2186940"/>
           </a:xfrm>
           <a:prstGeom prst="rect">
             <a:avLst/>
@@ -5303,11 +5303,11 @@
         <p:spPr>
           <a:xfrm>
             <a:off x="640080" y="1965960"/>
-            <a:ext cx="10911535" cy="1069848"/>
+            <a:ext cx="10911535" cy="815340"/>
           </a:xfrm>
           <a:prstGeom prst="roundRect">
             <a:avLst>
-              <a:gd name="adj" fmla="val 6838"/>
+              <a:gd name="adj" fmla="val 8972"/>
             </a:avLst>
           </a:prstGeom>
           <a:solidFill>
@@ -5325,7 +5325,7 @@
         <p:spPr>
           <a:xfrm>
             <a:off x="960120" y="2194560"/>
-            <a:ext cx="10271455" cy="612648"/>
+            <a:ext cx="10271455" cy="358140"/>
           </a:xfrm>
           <a:prstGeom prst="rect">
             <a:avLst/>
@@ -5366,8 +5366,8 @@
         </p:nvSpPr>
         <p:spPr>
           <a:xfrm>
-            <a:off x="640080" y="3264408"/>
-            <a:ext cx="10911535" cy="2999232"/>
+            <a:off x="640080" y="3009900"/>
+            <a:ext cx="10911535" cy="3253740"/>
           </a:xfrm>
           <a:prstGeom prst="rect">
             <a:avLst/>
@@ -5840,11 +5840,11 @@
         <p:spPr>
           <a:xfrm>
             <a:off x="640080" y="1965960"/>
-            <a:ext cx="10911535" cy="1837944"/>
+            <a:ext cx="10911535" cy="1348740"/>
           </a:xfrm>
           <a:prstGeom prst="roundRect">
             <a:avLst>
-              <a:gd name="adj" fmla="val 3980"/>
+              <a:gd name="adj" fmla="val 5424"/>
             </a:avLst>
           </a:prstGeom>
           <a:solidFill>
@@ -5862,7 +5862,7 @@
         <p:spPr>
           <a:xfrm>
             <a:off x="960120" y="2194560"/>
-            <a:ext cx="10271455" cy="1380744"/>
+            <a:ext cx="10271455" cy="891540"/>
           </a:xfrm>
           <a:prstGeom prst="rect">
             <a:avLst/>
@@ -6378,11 +6378,11 @@
         <p:spPr>
           <a:xfrm>
             <a:off x="640080" y="1965960"/>
-            <a:ext cx="10911535" cy="2990088"/>
+            <a:ext cx="10911535" cy="2148840"/>
           </a:xfrm>
           <a:prstGeom prst="roundRect">
             <a:avLst>
-              <a:gd name="adj" fmla="val 2446"/>
+              <a:gd name="adj" fmla="val 3404"/>
             </a:avLst>
           </a:prstGeom>
           <a:solidFill>
@@ -6400,7 +6400,7 @@
         <p:spPr>
           <a:xfrm>
             <a:off x="960120" y="2194560"/>
-            <a:ext cx="10271455" cy="2532888"/>
+            <a:ext cx="10271455" cy="1691640"/>
           </a:xfrm>
           <a:prstGeom prst="rect">
             <a:avLst/>
@@ -7654,11 +7654,11 @@
         <p:spPr>
           <a:xfrm>
             <a:off x="640080" y="1965960"/>
-            <a:ext cx="10911535" cy="1837944"/>
+            <a:ext cx="10911535" cy="1348740"/>
           </a:xfrm>
           <a:prstGeom prst="roundRect">
             <a:avLst>
-              <a:gd name="adj" fmla="val 3980"/>
+              <a:gd name="adj" fmla="val 5424"/>
             </a:avLst>
           </a:prstGeom>
           <a:solidFill>
@@ -7676,7 +7676,7 @@
         <p:spPr>
           <a:xfrm>
             <a:off x="960120" y="2194560"/>
-            <a:ext cx="10271455" cy="1380744"/>
+            <a:ext cx="10271455" cy="891540"/>
           </a:xfrm>
           <a:prstGeom prst="rect">
             <a:avLst/>
@@ -7757,8 +7757,8 @@
         </p:nvSpPr>
         <p:spPr>
           <a:xfrm>
-            <a:off x="640080" y="4032504"/>
-            <a:ext cx="10911535" cy="2231136"/>
+            <a:off x="640080" y="3543300"/>
+            <a:ext cx="10911535" cy="2720340"/>
           </a:xfrm>
           <a:prstGeom prst="rect">
             <a:avLst/>
@@ -8231,11 +8231,11 @@
         <p:spPr>
           <a:xfrm>
             <a:off x="640080" y="1965960"/>
-            <a:ext cx="10911535" cy="2606040"/>
+            <a:ext cx="10911535" cy="1882140"/>
           </a:xfrm>
           <a:prstGeom prst="roundRect">
             <a:avLst>
-              <a:gd name="adj" fmla="val 2807"/>
+              <a:gd name="adj" fmla="val 3887"/>
             </a:avLst>
           </a:prstGeom>
           <a:solidFill>
@@ -8253,7 +8253,7 @@
         <p:spPr>
           <a:xfrm>
             <a:off x="960120" y="2194560"/>
-            <a:ext cx="10271455" cy="2148840"/>
+            <a:ext cx="10271455" cy="1424940"/>
           </a:xfrm>
           <a:prstGeom prst="rect">
             <a:avLst/>
@@ -8374,8 +8374,8 @@
         </p:nvSpPr>
         <p:spPr>
           <a:xfrm>
-            <a:off x="640080" y="4800600"/>
-            <a:ext cx="10911535" cy="1463040"/>
+            <a:off x="640080" y="4076700"/>
+            <a:ext cx="10911535" cy="2186940"/>
           </a:xfrm>
           <a:prstGeom prst="rect">
             <a:avLst/>
@@ -8848,11 +8848,11 @@
         <p:spPr>
           <a:xfrm>
             <a:off x="640080" y="1965960"/>
-            <a:ext cx="10911535" cy="1453896"/>
+            <a:ext cx="10911535" cy="1082040"/>
           </a:xfrm>
           <a:prstGeom prst="roundRect">
             <a:avLst>
-              <a:gd name="adj" fmla="val 5031"/>
+              <a:gd name="adj" fmla="val 6761"/>
             </a:avLst>
           </a:prstGeom>
           <a:solidFill>
@@ -8870,7 +8870,7 @@
         <p:spPr>
           <a:xfrm>
             <a:off x="960120" y="2194560"/>
-            <a:ext cx="10271455" cy="996696"/>
+            <a:ext cx="10271455" cy="624840"/>
           </a:xfrm>
           <a:prstGeom prst="rect">
             <a:avLst/>
@@ -8931,8 +8931,8 @@
         </p:nvSpPr>
         <p:spPr>
           <a:xfrm>
-            <a:off x="640080" y="3648456"/>
-            <a:ext cx="10911535" cy="2615184"/>
+            <a:off x="640080" y="3276600"/>
+            <a:ext cx="10911535" cy="2987040"/>
           </a:xfrm>
           <a:prstGeom prst="rect">
             <a:avLst/>
@@ -9405,11 +9405,11 @@
         <p:spPr>
           <a:xfrm>
             <a:off x="640080" y="1965960"/>
-            <a:ext cx="10911535" cy="2221992"/>
+            <a:ext cx="10911535" cy="1615440"/>
           </a:xfrm>
           <a:prstGeom prst="roundRect">
             <a:avLst>
-              <a:gd name="adj" fmla="val 3292"/>
+              <a:gd name="adj" fmla="val 4528"/>
             </a:avLst>
           </a:prstGeom>
           <a:solidFill>
@@ -9427,7 +9427,7 @@
         <p:spPr>
           <a:xfrm>
             <a:off x="960120" y="2194560"/>
-            <a:ext cx="10271455" cy="1764792"/>
+            <a:ext cx="10271455" cy="1158240"/>
           </a:xfrm>
           <a:prstGeom prst="rect">
             <a:avLst/>
@@ -9528,8 +9528,8 @@
         </p:nvSpPr>
         <p:spPr>
           <a:xfrm>
-            <a:off x="640080" y="4416552"/>
-            <a:ext cx="10911535" cy="1847088"/>
+            <a:off x="640080" y="3810000"/>
+            <a:ext cx="10911535" cy="2453640"/>
           </a:xfrm>
           <a:prstGeom prst="rect">
             <a:avLst/>
@@ -10002,11 +10002,11 @@
         <p:spPr>
           <a:xfrm>
             <a:off x="640080" y="1965960"/>
-            <a:ext cx="10911535" cy="3291840"/>
+            <a:ext cx="10911535" cy="2415540"/>
           </a:xfrm>
           <a:prstGeom prst="roundRect">
             <a:avLst>
-              <a:gd name="adj" fmla="val 2222"/>
+              <a:gd name="adj" fmla="val 3028"/>
             </a:avLst>
           </a:prstGeom>
           <a:solidFill>
@@ -10024,7 +10024,7 @@
         <p:spPr>
           <a:xfrm>
             <a:off x="960120" y="2194560"/>
-            <a:ext cx="10271455" cy="2834640"/>
+            <a:ext cx="10271455" cy="1958340"/>
           </a:xfrm>
           <a:prstGeom prst="rect">
             <a:avLst/>
@@ -10185,8 +10185,8 @@
         </p:nvSpPr>
         <p:spPr>
           <a:xfrm>
-            <a:off x="640080" y="5486400"/>
-            <a:ext cx="10911535" cy="777240"/>
+            <a:off x="640080" y="4610100"/>
+            <a:ext cx="10911535" cy="1653540"/>
           </a:xfrm>
           <a:prstGeom prst="rect">
             <a:avLst/>
@@ -10659,11 +10659,11 @@
         <p:spPr>
           <a:xfrm>
             <a:off x="640080" y="1965960"/>
-            <a:ext cx="10911535" cy="1069848"/>
+            <a:ext cx="10911535" cy="815340"/>
           </a:xfrm>
           <a:prstGeom prst="roundRect">
             <a:avLst>
-              <a:gd name="adj" fmla="val 6838"/>
+              <a:gd name="adj" fmla="val 8972"/>
             </a:avLst>
           </a:prstGeom>
           <a:solidFill>
@@ -10681,7 +10681,7 @@
         <p:spPr>
           <a:xfrm>
             <a:off x="960120" y="2194560"/>
-            <a:ext cx="10271455" cy="612648"/>
+            <a:ext cx="10271455" cy="358140"/>
           </a:xfrm>
           <a:prstGeom prst="rect">
             <a:avLst/>
@@ -10722,8 +10722,8 @@
         </p:nvSpPr>
         <p:spPr>
           <a:xfrm>
-            <a:off x="640080" y="3264408"/>
-            <a:ext cx="10911535" cy="2999232"/>
+            <a:off x="640080" y="3009900"/>
+            <a:ext cx="10911535" cy="3253740"/>
           </a:xfrm>
           <a:prstGeom prst="rect">
             <a:avLst/>
@@ -12275,11 +12275,11 @@
         <p:spPr>
           <a:xfrm>
             <a:off x="640080" y="1965960"/>
-            <a:ext cx="10911535" cy="3931920"/>
+            <a:ext cx="10911535" cy="3215640"/>
           </a:xfrm>
           <a:prstGeom prst="roundRect">
             <a:avLst>
-              <a:gd name="adj" fmla="val 1860"/>
+              <a:gd name="adj" fmla="val 2275"/>
             </a:avLst>
           </a:prstGeom>
           <a:solidFill>
@@ -12297,7 +12297,7 @@
         <p:spPr>
           <a:xfrm>
             <a:off x="960120" y="2194560"/>
-            <a:ext cx="10271455" cy="3474720"/>
+            <a:ext cx="10271455" cy="2758440"/>
           </a:xfrm>
           <a:prstGeom prst="rect">
             <a:avLst/>
@@ -14013,12 +14013,116 @@
         </p:nvSpPr>
         <p:spPr>
           <a:xfrm>
-            <a:off x="530352" y="2221992"/>
-            <a:ext cx="11130991" cy="4059936"/>
+            <a:off x="640080" y="2240280"/>
+            <a:ext cx="10911535" cy="1263015"/>
           </a:xfrm>
           <a:prstGeom prst="roundRect">
             <a:avLst>
-              <a:gd name="adj" fmla="val 1351"/>
+              <a:gd name="adj" fmla="val 5792"/>
+            </a:avLst>
+          </a:prstGeom>
+          <a:solidFill>
+            <a:srgbClr val="1E1E4C"/>
+          </a:solidFill>
+          <a:ln/>
+        </p:spPr>
+      </p:sp>
+      <p:sp>
+        <p:nvSpPr>
+          <p:cNvPr id="6" name="Text 4"/>
+          <p:cNvSpPr txBox="1"/>
+          <p:nvPr/>
+        </p:nvSpPr>
+        <p:spPr>
+          <a:xfrm>
+            <a:off x="960120" y="2468880"/>
+            <a:ext cx="10271455" cy="805815"/>
+          </a:xfrm>
+          <a:prstGeom prst="rect">
+            <a:avLst/>
+          </a:prstGeom>
+          <a:noFill/>
+          <a:ln/>
+        </p:spPr>
+        <p:txBody>
+          <a:bodyPr wrap="square" lIns="0" tIns="0" rIns="0" bIns="0" rtlCol="0" anchor="t"/>
+          <a:lstStyle/>
+          <a:p>
+            <a:pPr indent="0" marL="0">
+              <a:lnSpc>
+                <a:spcPct val="125000"/>
+              </a:lnSpc>
+              <a:buNone/>
+            </a:pPr>
+            <a:r>
+              <a:rPr lang="en-US" sz="1250" dirty="0">
+                <a:solidFill>
+                  <a:srgbClr val="C9D3F5"/>
+                </a:solidFill>
+                <a:latin typeface="Courier New" pitchFamily="34" charset="0"/>
+                <a:ea typeface="Courier New" pitchFamily="34" charset="-122"/>
+                <a:cs typeface="Courier New" pitchFamily="34" charset="-120"/>
+              </a:rPr>
+              <a:t>.flex-row {</a:t>
+            </a:r>
+            <a:endParaRPr lang="en-US" sz="1250" dirty="0"/>
+          </a:p>
+          <a:p>
+            <a:pPr indent="0" marL="0">
+              <a:lnSpc>
+                <a:spcPct val="125000"/>
+              </a:lnSpc>
+              <a:buNone/>
+            </a:pPr>
+            <a:r>
+              <a:rPr lang="en-US" sz="1250" dirty="0">
+                <a:solidFill>
+                  <a:srgbClr val="C9D3F5"/>
+                </a:solidFill>
+                <a:latin typeface="Courier New" pitchFamily="34" charset="0"/>
+                <a:ea typeface="Courier New" pitchFamily="34" charset="-122"/>
+                <a:cs typeface="Courier New" pitchFamily="34" charset="-120"/>
+              </a:rPr>
+              <a:t>  display: flex; /* main axis: horizontal, left to right */</a:t>
+            </a:r>
+            <a:endParaRPr lang="en-US" sz="1250" dirty="0"/>
+          </a:p>
+          <a:p>
+            <a:pPr indent="0" marL="0">
+              <a:lnSpc>
+                <a:spcPct val="125000"/>
+              </a:lnSpc>
+              <a:buNone/>
+            </a:pPr>
+            <a:r>
+              <a:rPr lang="en-US" sz="1250" dirty="0">
+                <a:solidFill>
+                  <a:srgbClr val="C9D3F5"/>
+                </a:solidFill>
+                <a:latin typeface="Courier New" pitchFamily="34" charset="0"/>
+                <a:ea typeface="Courier New" pitchFamily="34" charset="-122"/>
+                <a:cs typeface="Courier New" pitchFamily="34" charset="-120"/>
+              </a:rPr>
+              <a:t>}</a:t>
+            </a:r>
+            <a:endParaRPr lang="en-US" sz="1250" dirty="0"/>
+          </a:p>
+        </p:txBody>
+      </p:sp>
+      <p:sp>
+        <p:nvSpPr>
+          <p:cNvPr id="7" name="Shape 5"/>
+          <p:cNvSpPr/>
+          <p:nvPr/>
+        </p:nvSpPr>
+        <p:spPr>
+          <a:xfrm>
+            <a:off x="530352" y="3667887"/>
+            <a:ext cx="11130991" cy="2659761"/>
+          </a:xfrm>
+          <a:prstGeom prst="roundRect">
+            <a:avLst>
+              <a:gd name="adj" fmla="val 2063"/>
             </a:avLst>
           </a:prstGeom>
           <a:solidFill>
@@ -14041,7 +14145,7 @@
       </p:sp>
       <p:pic>
         <p:nvPicPr>
-          <p:cNvPr id="6" name="Image 0" descr="D:/GitHub/mern-web-book/docs/assets/img/lecture-09/main-cross-axis.png">    </p:cNvPr>
+          <p:cNvPr id="8" name="Image 0" descr="D:/GitHub/mern-web-book/docs/assets/img/lecture-09/main-cross-axis.png">    </p:cNvPr>
           <p:cNvPicPr>
             <a:picLocks noChangeAspect="1"/>
           </p:cNvPicPr>
@@ -14055,8 +14159,8 @@
         </p:blipFill>
         <p:spPr>
           <a:xfrm>
-            <a:off x="1406031" y="2331720"/>
-            <a:ext cx="9379634" cy="3840480"/>
+            <a:off x="3115860" y="3777615"/>
+            <a:ext cx="5959976" cy="2440305"/>
           </a:xfrm>
           <a:prstGeom prst="rect">
             <a:avLst/>
@@ -14065,7 +14169,7 @@
       </p:pic>
       <p:sp>
         <p:nvSpPr>
-          <p:cNvPr id="7" name="Text 4"/>
+          <p:cNvPr id="9" name="Text 6"/>
           <p:cNvSpPr txBox="1"/>
           <p:nvPr/>
         </p:nvSpPr>
@@ -14104,7 +14208,7 @@
       </p:sp>
       <p:sp>
         <p:nvSpPr>
-          <p:cNvPr id="8" name="Text 5"/>
+          <p:cNvPr id="10" name="Text 7"/>
           <p:cNvSpPr txBox="1"/>
           <p:nvPr/>
         </p:nvSpPr>
@@ -14260,11 +14364,11 @@
         <p:spPr>
           <a:xfrm>
             <a:off x="640080" y="1965960"/>
-            <a:ext cx="10911535" cy="1069848"/>
+            <a:ext cx="10911535" cy="815340"/>
           </a:xfrm>
           <a:prstGeom prst="roundRect">
             <a:avLst>
-              <a:gd name="adj" fmla="val 6838"/>
+              <a:gd name="adj" fmla="val 8972"/>
             </a:avLst>
           </a:prstGeom>
           <a:solidFill>
@@ -14282,7 +14386,7 @@
         <p:spPr>
           <a:xfrm>
             <a:off x="960120" y="2194560"/>
-            <a:ext cx="10271455" cy="612648"/>
+            <a:ext cx="10271455" cy="358140"/>
           </a:xfrm>
           <a:prstGeom prst="rect">
             <a:avLst/>
@@ -14758,11 +14862,11 @@
         <p:spPr>
           <a:xfrm>
             <a:off x="640080" y="1965960"/>
-            <a:ext cx="10911535" cy="1453896"/>
+            <a:ext cx="10911535" cy="1082040"/>
           </a:xfrm>
           <a:prstGeom prst="roundRect">
             <a:avLst>
-              <a:gd name="adj" fmla="val 5031"/>
+              <a:gd name="adj" fmla="val 6761"/>
             </a:avLst>
           </a:prstGeom>
           <a:solidFill>
@@ -14780,7 +14884,7 @@
         <p:spPr>
           <a:xfrm>
             <a:off x="960120" y="2194560"/>
-            <a:ext cx="10271455" cy="996696"/>
+            <a:ext cx="10271455" cy="624840"/>
           </a:xfrm>
           <a:prstGeom prst="rect">
             <a:avLst/>

</xml_diff>